<commit_message>
카탈로그 PPTX 글꼴을 Pretendard(latin·ea·cs)로 고정
Co-Authored-By: Claude Sonnet 5.5 <noreply@anthropic.com>
Claude-Session: https://claude.ai/code/session_01Utnchprio7QaXNtc18keen
</commit_message>
<xml_diff>
--- a/korad-경영평가-ppt/layouts/KORAD_경영평가_레이아웃_카탈로그.pptx
+++ b/korad-경영평가-ppt/layouts/KORAD_경영평가_레이아웃_카탈로그.pptx
@@ -3137,6 +3137,8 @@
                   <a:srgbClr val="000359"/>
                 </a:solidFill>
                 <a:latin typeface="Pretendard"/>
+                <a:ea typeface="Pretendard"/>
+                <a:cs typeface="Pretendard"/>
               </a:rPr>
               <a:t>KORAD 경영평가 레이아웃 카탈로그 (누적)</a:t>
             </a:r>
@@ -3187,6 +3189,8 @@
                   <a:srgbClr val="3B4951"/>
                 </a:solidFill>
                 <a:latin typeface="Pretendard"/>
+                <a:ea typeface="Pretendard"/>
+                <a:cs typeface="Pretendard"/>
               </a:rPr>
               <a:t>프레임 2종 · 블록 레이아웃 25종 · 쪽 레이아웃 5종
 PG-01  Ⅳ-평가내용1-1-가  [p05]
@@ -3285,6 +3289,8 @@
                   <a:srgbClr val="000359"/>
                 </a:solidFill>
                 <a:latin typeface="Pretendard"/>
+                <a:ea typeface="Pretendard"/>
+                <a:cs typeface="Pretendard"/>
               </a:rPr>
               <a:t>PG-01  Ⅳ-평가내용1-1-가  (p05)</a:t>
             </a:r>
@@ -3337,6 +3343,8 @@
                   <a:srgbClr val="000359"/>
                 </a:solidFill>
                 <a:latin typeface="Pretendard"/>
+                <a:ea typeface="Pretendard"/>
+                <a:cs typeface="Pretendard"/>
               </a:rPr>
               <a:t/>
             </a:r>
@@ -3391,6 +3399,8 @@
                   <a:srgbClr val="000359"/>
                 </a:solidFill>
                 <a:latin typeface="Pretendard"/>
+                <a:ea typeface="Pretendard"/>
+                <a:cs typeface="Pretendard"/>
               </a:rPr>
               <a:t>BL-001 chapter_title </a:t>
             </a:r>
@@ -3445,6 +3455,8 @@
                   <a:srgbClr val="000359"/>
                 </a:solidFill>
                 <a:latin typeface="Pretendard"/>
+                <a:ea typeface="Pretendard"/>
+                <a:cs typeface="Pretendard"/>
               </a:rPr>
               <a:t>BL-002 eval_item_box </a:t>
             </a:r>
@@ -3499,6 +3511,8 @@
                   <a:srgbClr val="000359"/>
                 </a:solidFill>
                 <a:latin typeface="Pretendard"/>
+                <a:ea typeface="Pretendard"/>
+                <a:cs typeface="Pretendard"/>
               </a:rPr>
               <a:t>BL-003 bp_banner </a:t>
             </a:r>
@@ -3553,6 +3567,8 @@
                   <a:srgbClr val="FFFFFF"/>
                 </a:solidFill>
                 <a:latin typeface="Pretendard"/>
+                <a:ea typeface="Pretendard"/>
+                <a:cs typeface="Pretendard"/>
               </a:rPr>
               <a:t>BL-004 section_bar </a:t>
             </a:r>
@@ -3607,6 +3623,8 @@
                   <a:srgbClr val="000359"/>
                 </a:solidFill>
                 <a:latin typeface="Pretendard"/>
+                <a:ea typeface="Pretendard"/>
+                <a:cs typeface="Pretendard"/>
               </a:rPr>
               <a:t>BL-005 subhead </a:t>
             </a:r>
@@ -3661,6 +3679,8 @@
                   <a:srgbClr val="FFFFFF"/>
                 </a:solidFill>
                 <a:latin typeface="Pretendard"/>
+                <a:ea typeface="Pretendard"/>
+                <a:cs typeface="Pretendard"/>
               </a:rPr>
               <a:t>BL-006 labeled_block 환경진단</a:t>
             </a:r>
@@ -3713,6 +3733,8 @@
                   <a:srgbClr val="000359"/>
                 </a:solidFill>
                 <a:latin typeface="Pretendard"/>
+                <a:ea typeface="Pretendard"/>
+                <a:cs typeface="Pretendard"/>
               </a:rPr>
               <a:t/>
             </a:r>
@@ -3765,6 +3787,8 @@
                   <a:srgbClr val="3B4951"/>
                 </a:solidFill>
                 <a:latin typeface="Pretendard"/>
+                <a:ea typeface="Pretendard"/>
+                <a:cs typeface="Pretendard"/>
               </a:rPr>
               <a:t>card_tl</a:t>
             </a:r>
@@ -3817,6 +3841,8 @@
                   <a:srgbClr val="3B4951"/>
                 </a:solidFill>
                 <a:latin typeface="Pretendard"/>
+                <a:ea typeface="Pretendard"/>
+                <a:cs typeface="Pretendard"/>
               </a:rPr>
               <a:t>card_tr</a:t>
             </a:r>
@@ -3869,6 +3895,8 @@
                   <a:srgbClr val="3B4951"/>
                 </a:solidFill>
                 <a:latin typeface="Pretendard"/>
+                <a:ea typeface="Pretendard"/>
+                <a:cs typeface="Pretendard"/>
               </a:rPr>
               <a:t>card_bl</a:t>
             </a:r>
@@ -3921,6 +3949,8 @@
                   <a:srgbClr val="3B4951"/>
                 </a:solidFill>
                 <a:latin typeface="Pretendard"/>
+                <a:ea typeface="Pretendard"/>
+                <a:cs typeface="Pretendard"/>
               </a:rPr>
               <a:t>card_br</a:t>
             </a:r>
@@ -3973,6 +4003,8 @@
                   <a:srgbClr val="3B4951"/>
                 </a:solidFill>
                 <a:latin typeface="Pretendard"/>
+                <a:ea typeface="Pretendard"/>
+                <a:cs typeface="Pretendard"/>
               </a:rPr>
               <a:t>hub_circle_images</a:t>
             </a:r>
@@ -4027,6 +4059,8 @@
                   <a:srgbClr val="000359"/>
                 </a:solidFill>
                 <a:latin typeface="Pretendard"/>
+                <a:ea typeface="Pretendard"/>
+                <a:cs typeface="Pretendard"/>
               </a:rPr>
               <a:t>BL-007 insight_bar </a:t>
             </a:r>
@@ -4081,6 +4115,8 @@
                   <a:srgbClr val="FFFFFF"/>
                 </a:solidFill>
                 <a:latin typeface="Pretendard"/>
+                <a:ea typeface="Pretendard"/>
+                <a:cs typeface="Pretendard"/>
               </a:rPr>
               <a:t>BL-008 labeled_block 기존해석/변화필요성/설립목적재정의</a:t>
             </a:r>
@@ -4133,6 +4169,8 @@
                   <a:srgbClr val="000359"/>
                 </a:solidFill>
                 <a:latin typeface="Pretendard"/>
+                <a:ea typeface="Pretendard"/>
+                <a:cs typeface="Pretendard"/>
               </a:rPr>
               <a:t/>
             </a:r>
@@ -4185,6 +4223,8 @@
                   <a:srgbClr val="3B4951"/>
                 </a:solidFill>
                 <a:latin typeface="Pretendard"/>
+                <a:ea typeface="Pretendard"/>
+                <a:cs typeface="Pretendard"/>
               </a:rPr>
               <a:t>label_chevron_stack</a:t>
             </a:r>
@@ -4237,6 +4277,8 @@
                   <a:srgbClr val="3B4951"/>
                 </a:solidFill>
                 <a:latin typeface="Pretendard"/>
+                <a:ea typeface="Pretendard"/>
+                <a:cs typeface="Pretendard"/>
               </a:rPr>
               <a:t>top_pair_strip</a:t>
             </a:r>
@@ -4289,6 +4331,8 @@
                   <a:srgbClr val="3B4951"/>
                 </a:solidFill>
                 <a:latin typeface="Pretendard"/>
+                <a:ea typeface="Pretendard"/>
+                <a:cs typeface="Pretendard"/>
               </a:rPr>
               <a:t>row1_cells</a:t>
             </a:r>
@@ -4341,6 +4385,8 @@
                   <a:srgbClr val="3B4951"/>
                 </a:solidFill>
                 <a:latin typeface="Pretendard"/>
+                <a:ea typeface="Pretendard"/>
+                <a:cs typeface="Pretendard"/>
               </a:rPr>
               <a:t>row2_cells</a:t>
             </a:r>
@@ -4393,6 +4439,8 @@
                   <a:srgbClr val="3B4951"/>
                 </a:solidFill>
                 <a:latin typeface="Pretendard"/>
+                <a:ea typeface="Pretendard"/>
+                <a:cs typeface="Pretendard"/>
               </a:rPr>
               <a:t>row3_cells</a:t>
             </a:r>
@@ -4445,6 +4493,8 @@
                   <a:srgbClr val="3B4951"/>
                 </a:solidFill>
                 <a:latin typeface="Pretendard"/>
+                <a:ea typeface="Pretendard"/>
+                <a:cs typeface="Pretendard"/>
               </a:rPr>
               <a:t>bottom_conclusion_bar</a:t>
             </a:r>
@@ -4513,6 +4563,8 @@
                   <a:srgbClr val="000359"/>
                 </a:solidFill>
                 <a:latin typeface="Pretendard"/>
+                <a:ea typeface="Pretendard"/>
+                <a:cs typeface="Pretendard"/>
               </a:rPr>
               <a:t>PG-02  Ⅳ-평가내용1-1-나·다  (p06)</a:t>
             </a:r>
@@ -4565,6 +4617,8 @@
                   <a:srgbClr val="000359"/>
                 </a:solidFill>
                 <a:latin typeface="Pretendard"/>
+                <a:ea typeface="Pretendard"/>
+                <a:cs typeface="Pretendard"/>
               </a:rPr>
               <a:t/>
             </a:r>
@@ -4619,6 +4673,8 @@
                   <a:srgbClr val="000359"/>
                 </a:solidFill>
                 <a:latin typeface="Pretendard"/>
+                <a:ea typeface="Pretendard"/>
+                <a:cs typeface="Pretendard"/>
               </a:rPr>
               <a:t>BL-005 subhead </a:t>
             </a:r>
@@ -4673,6 +4729,8 @@
                   <a:srgbClr val="FFFFFF"/>
                 </a:solidFill>
                 <a:latin typeface="Pretendard"/>
+                <a:ea typeface="Pretendard"/>
+                <a:cs typeface="Pretendard"/>
               </a:rPr>
               <a:t>BL-009 labeled_block 이해관계자 재분류</a:t>
             </a:r>
@@ -4725,6 +4783,8 @@
                   <a:srgbClr val="000359"/>
                 </a:solidFill>
                 <a:latin typeface="Pretendard"/>
+                <a:ea typeface="Pretendard"/>
+                <a:cs typeface="Pretendard"/>
               </a:rPr>
               <a:t/>
             </a:r>
@@ -4777,6 +4837,8 @@
                   <a:srgbClr val="3B4951"/>
                 </a:solidFill>
                 <a:latin typeface="Pretendard"/>
+                <a:ea typeface="Pretendard"/>
+                <a:cs typeface="Pretendard"/>
               </a:rPr>
               <a:t>top_banner</a:t>
             </a:r>
@@ -4829,6 +4891,8 @@
                   <a:srgbClr val="3B4951"/>
                 </a:solidFill>
                 <a:latin typeface="Pretendard"/>
+                <a:ea typeface="Pretendard"/>
+                <a:cs typeface="Pretendard"/>
               </a:rPr>
               <a:t>chevron_process_4step</a:t>
             </a:r>
@@ -4881,6 +4945,8 @@
                   <a:srgbClr val="3B4951"/>
                 </a:solidFill>
                 <a:latin typeface="Pretendard"/>
+                <a:ea typeface="Pretendard"/>
+                <a:cs typeface="Pretendard"/>
               </a:rPr>
               <a:t>card_tl</a:t>
             </a:r>
@@ -4933,6 +4999,8 @@
                   <a:srgbClr val="3B4951"/>
                 </a:solidFill>
                 <a:latin typeface="Pretendard"/>
+                <a:ea typeface="Pretendard"/>
+                <a:cs typeface="Pretendard"/>
               </a:rPr>
               <a:t>card_tr</a:t>
             </a:r>
@@ -4985,6 +5053,8 @@
                   <a:srgbClr val="3B4951"/>
                 </a:solidFill>
                 <a:latin typeface="Pretendard"/>
+                <a:ea typeface="Pretendard"/>
+                <a:cs typeface="Pretendard"/>
               </a:rPr>
               <a:t>card_bl</a:t>
             </a:r>
@@ -5037,6 +5107,8 @@
                   <a:srgbClr val="3B4951"/>
                 </a:solidFill>
                 <a:latin typeface="Pretendard"/>
+                <a:ea typeface="Pretendard"/>
+                <a:cs typeface="Pretendard"/>
               </a:rPr>
               <a:t>card_br</a:t>
             </a:r>
@@ -5091,6 +5163,8 @@
                   <a:srgbClr val="000359"/>
                 </a:solidFill>
                 <a:latin typeface="Pretendard"/>
+                <a:ea typeface="Pretendard"/>
+                <a:cs typeface="Pretendard"/>
               </a:rPr>
               <a:t>BL-010 arrow_caption </a:t>
             </a:r>
@@ -5145,6 +5219,8 @@
                   <a:srgbClr val="FFFFFF"/>
                 </a:solidFill>
                 <a:latin typeface="Pretendard"/>
+                <a:ea typeface="Pretendard"/>
+                <a:cs typeface="Pretendard"/>
               </a:rPr>
               <a:t>BL-011 labeled_block 가치전략 진단</a:t>
             </a:r>
@@ -5197,6 +5273,8 @@
                   <a:srgbClr val="000359"/>
                 </a:solidFill>
                 <a:latin typeface="Pretendard"/>
+                <a:ea typeface="Pretendard"/>
+                <a:cs typeface="Pretendard"/>
               </a:rPr>
               <a:t/>
             </a:r>
@@ -5249,6 +5327,8 @@
                   <a:srgbClr val="3B4951"/>
                 </a:solidFill>
                 <a:latin typeface="Pretendard"/>
+                <a:ea typeface="Pretendard"/>
+                <a:cs typeface="Pretendard"/>
               </a:rPr>
               <a:t>lead_bullets</a:t>
             </a:r>
@@ -5301,6 +5381,8 @@
                   <a:srgbClr val="3B4951"/>
                 </a:solidFill>
                 <a:latin typeface="Pretendard"/>
+                <a:ea typeface="Pretendard"/>
+                <a:cs typeface="Pretendard"/>
               </a:rPr>
               <a:t>col3_header</a:t>
             </a:r>
@@ -5353,6 +5435,8 @@
                   <a:srgbClr val="3B4951"/>
                 </a:solidFill>
                 <a:latin typeface="Pretendard"/>
+                <a:ea typeface="Pretendard"/>
+                <a:cs typeface="Pretendard"/>
               </a:rPr>
               <a:t>col3_body</a:t>
             </a:r>
@@ -5405,6 +5489,8 @@
                   <a:srgbClr val="3B4951"/>
                 </a:solidFill>
                 <a:latin typeface="Pretendard"/>
+                <a:ea typeface="Pretendard"/>
+                <a:cs typeface="Pretendard"/>
               </a:rPr>
               <a:t>message_band</a:t>
             </a:r>
@@ -5457,6 +5543,8 @@
                   <a:srgbClr val="3B4951"/>
                 </a:solidFill>
                 <a:latin typeface="Pretendard"/>
+                <a:ea typeface="Pretendard"/>
+                <a:cs typeface="Pretendard"/>
               </a:rPr>
               <a:t>table_row_value</a:t>
             </a:r>
@@ -5509,6 +5597,8 @@
                   <a:srgbClr val="3B4951"/>
                 </a:solidFill>
                 <a:latin typeface="Pretendard"/>
+                <a:ea typeface="Pretendard"/>
+                <a:cs typeface="Pretendard"/>
               </a:rPr>
               <a:t>table_row_strategy</a:t>
             </a:r>
@@ -5561,6 +5651,8 @@
                   <a:srgbClr val="3B4951"/>
                 </a:solidFill>
                 <a:latin typeface="Pretendard"/>
+                <a:ea typeface="Pretendard"/>
+                <a:cs typeface="Pretendard"/>
               </a:rPr>
               <a:t>check_column</a:t>
             </a:r>
@@ -5615,6 +5707,8 @@
                   <a:srgbClr val="000359"/>
                 </a:solidFill>
                 <a:latin typeface="Pretendard"/>
+                <a:ea typeface="Pretendard"/>
+                <a:cs typeface="Pretendard"/>
               </a:rPr>
               <a:t>BL-012 rolling_block </a:t>
             </a:r>
@@ -5667,6 +5761,8 @@
                   <a:srgbClr val="3B4951"/>
                 </a:solidFill>
                 <a:latin typeface="Pretendard"/>
+                <a:ea typeface="Pretendard"/>
+                <a:cs typeface="Pretendard"/>
               </a:rPr>
               <a:t>ribbon_title</a:t>
             </a:r>
@@ -5719,6 +5815,8 @@
                   <a:srgbClr val="3B4951"/>
                 </a:solidFill>
                 <a:latin typeface="Pretendard"/>
+                <a:ea typeface="Pretendard"/>
+                <a:cs typeface="Pretendard"/>
               </a:rPr>
               <a:t>chevron3_header</a:t>
             </a:r>
@@ -5771,6 +5869,8 @@
                   <a:srgbClr val="3B4951"/>
                 </a:solidFill>
                 <a:latin typeface="Pretendard"/>
+                <a:ea typeface="Pretendard"/>
+                <a:cs typeface="Pretendard"/>
               </a:rPr>
               <a:t>cards</a:t>
             </a:r>
@@ -5823,6 +5923,8 @@
                   <a:srgbClr val="3B4951"/>
                 </a:solidFill>
                 <a:latin typeface="Pretendard"/>
+                <a:ea typeface="Pretendard"/>
+                <a:cs typeface="Pretendard"/>
               </a:rPr>
               <a:t>desc_strip</a:t>
             </a:r>
@@ -5875,6 +5977,8 @@
                   <a:srgbClr val="3B4951"/>
                 </a:solidFill>
                 <a:latin typeface="Pretendard"/>
+                <a:ea typeface="Pretendard"/>
+                <a:cs typeface="Pretendard"/>
               </a:rPr>
               <a:t>bullets</a:t>
             </a:r>
@@ -5929,6 +6033,8 @@
                   <a:srgbClr val="000359"/>
                 </a:solidFill>
                 <a:latin typeface="Pretendard"/>
+                <a:ea typeface="Pretendard"/>
+                <a:cs typeface="Pretendard"/>
               </a:rPr>
               <a:t>BL-005 subhead </a:t>
             </a:r>
@@ -5983,6 +6089,8 @@
                   <a:srgbClr val="000359"/>
                 </a:solidFill>
                 <a:latin typeface="Pretendard"/>
+                <a:ea typeface="Pretendard"/>
+                <a:cs typeface="Pretendard"/>
               </a:rPr>
               <a:t>BL-013 matrix_plus_channels </a:t>
             </a:r>
@@ -6035,6 +6143,8 @@
                   <a:srgbClr val="3B4951"/>
                 </a:solidFill>
                 <a:latin typeface="Pretendard"/>
+                <a:ea typeface="Pretendard"/>
+                <a:cs typeface="Pretendard"/>
               </a:rPr>
               <a:t>quadrant_matrix</a:t>
             </a:r>
@@ -6087,6 +6197,8 @@
                   <a:srgbClr val="3B4951"/>
                 </a:solidFill>
                 <a:latin typeface="Pretendard"/>
+                <a:ea typeface="Pretendard"/>
+                <a:cs typeface="Pretendard"/>
               </a:rPr>
               <a:t>channel_by_type</a:t>
             </a:r>
@@ -6139,6 +6251,8 @@
                   <a:srgbClr val="3B4951"/>
                 </a:solidFill>
                 <a:latin typeface="Pretendard"/>
+                <a:ea typeface="Pretendard"/>
+                <a:cs typeface="Pretendard"/>
               </a:rPr>
               <a:t>spread_channels_with_thumbs</a:t>
             </a:r>
@@ -6207,6 +6321,8 @@
                   <a:srgbClr val="000359"/>
                 </a:solidFill>
                 <a:latin typeface="Pretendard"/>
+                <a:ea typeface="Pretendard"/>
+                <a:cs typeface="Pretendard"/>
               </a:rPr>
               <a:t>PG-03  Ⅳ-평가내용1-2  (p07)</a:t>
             </a:r>
@@ -6259,6 +6375,8 @@
                   <a:srgbClr val="000359"/>
                 </a:solidFill>
                 <a:latin typeface="Pretendard"/>
+                <a:ea typeface="Pretendard"/>
+                <a:cs typeface="Pretendard"/>
               </a:rPr>
               <a:t/>
             </a:r>
@@ -6313,6 +6431,8 @@
                   <a:srgbClr val="FFFFFF"/>
                 </a:solidFill>
                 <a:latin typeface="Pretendard"/>
+                <a:ea typeface="Pretendard"/>
+                <a:cs typeface="Pretendard"/>
               </a:rPr>
               <a:t>BL-004 section_bar </a:t>
             </a:r>
@@ -6367,6 +6487,8 @@
                   <a:srgbClr val="FFFFFF"/>
                 </a:solidFill>
                 <a:latin typeface="Pretendard"/>
+                <a:ea typeface="Pretendard"/>
+                <a:cs typeface="Pretendard"/>
               </a:rPr>
               <a:t>BL-014 labeled_block 그간의 혁신연계</a:t>
             </a:r>
@@ -6419,6 +6541,8 @@
                   <a:srgbClr val="000359"/>
                 </a:solidFill>
                 <a:latin typeface="Pretendard"/>
+                <a:ea typeface="Pretendard"/>
+                <a:cs typeface="Pretendard"/>
               </a:rPr>
               <a:t/>
             </a:r>
@@ -6471,6 +6595,8 @@
                   <a:srgbClr val="3B4951"/>
                 </a:solidFill>
                 <a:latin typeface="Pretendard"/>
+                <a:ea typeface="Pretendard"/>
+                <a:cs typeface="Pretendard"/>
               </a:rPr>
               <a:t>top_banner</a:t>
             </a:r>
@@ -6523,6 +6649,8 @@
                   <a:srgbClr val="3B4951"/>
                 </a:solidFill>
                 <a:latin typeface="Pretendard"/>
+                <a:ea typeface="Pretendard"/>
+                <a:cs typeface="Pretendard"/>
               </a:rPr>
               <a:t>year_chevron3</a:t>
             </a:r>
@@ -6575,6 +6703,8 @@
                   <a:srgbClr val="3B4951"/>
                 </a:solidFill>
                 <a:latin typeface="Pretendard"/>
+                <a:ea typeface="Pretendard"/>
+                <a:cs typeface="Pretendard"/>
               </a:rPr>
               <a:t>cols3_body</a:t>
             </a:r>
@@ -6629,6 +6759,8 @@
                   <a:srgbClr val="FFFFFF"/>
                 </a:solidFill>
                 <a:latin typeface="Pretendard"/>
+                <a:ea typeface="Pretendard"/>
+                <a:cs typeface="Pretendard"/>
               </a:rPr>
               <a:t>BL-015 tf_module AI First 전략기획단</a:t>
             </a:r>
@@ -6681,6 +6813,8 @@
                   <a:srgbClr val="000359"/>
                 </a:solidFill>
                 <a:latin typeface="Pretendard"/>
+                <a:ea typeface="Pretendard"/>
+                <a:cs typeface="Pretendard"/>
               </a:rPr>
               <a:t/>
             </a:r>
@@ -6733,6 +6867,8 @@
                   <a:srgbClr val="3B4951"/>
                 </a:solidFill>
                 <a:latin typeface="Pretendard"/>
+                <a:ea typeface="Pretendard"/>
+                <a:cs typeface="Pretendard"/>
               </a:rPr>
               <a:t>ribbon_title</a:t>
             </a:r>
@@ -6785,6 +6921,8 @@
                   <a:srgbClr val="3B4951"/>
                 </a:solidFill>
                 <a:latin typeface="Pretendard"/>
+                <a:ea typeface="Pretendard"/>
+                <a:cs typeface="Pretendard"/>
               </a:rPr>
               <a:t>flow_block</a:t>
             </a:r>
@@ -6837,6 +6975,8 @@
                   <a:srgbClr val="3B4951"/>
                 </a:solidFill>
                 <a:latin typeface="Pretendard"/>
+                <a:ea typeface="Pretendard"/>
+                <a:cs typeface="Pretendard"/>
               </a:rPr>
               <a:t>future_block</a:t>
             </a:r>
@@ -6891,6 +7031,8 @@
                   <a:srgbClr val="FFFFFF"/>
                 </a:solidFill>
                 <a:latin typeface="Pretendard"/>
+                <a:ea typeface="Pretendard"/>
+                <a:cs typeface="Pretendard"/>
               </a:rPr>
               <a:t>BL-015 tf_module 물에너지 Re:boot TF</a:t>
             </a:r>
@@ -6943,6 +7085,8 @@
                   <a:srgbClr val="000359"/>
                 </a:solidFill>
                 <a:latin typeface="Pretendard"/>
+                <a:ea typeface="Pretendard"/>
+                <a:cs typeface="Pretendard"/>
               </a:rPr>
               <a:t/>
             </a:r>
@@ -6995,6 +7139,8 @@
                   <a:srgbClr val="3B4951"/>
                 </a:solidFill>
                 <a:latin typeface="Pretendard"/>
+                <a:ea typeface="Pretendard"/>
+                <a:cs typeface="Pretendard"/>
               </a:rPr>
               <a:t>ribbon_title</a:t>
             </a:r>
@@ -7047,6 +7193,8 @@
                   <a:srgbClr val="3B4951"/>
                 </a:solidFill>
                 <a:latin typeface="Pretendard"/>
+                <a:ea typeface="Pretendard"/>
+                <a:cs typeface="Pretendard"/>
               </a:rPr>
               <a:t>flow_block</a:t>
             </a:r>
@@ -7099,6 +7247,8 @@
                   <a:srgbClr val="3B4951"/>
                 </a:solidFill>
                 <a:latin typeface="Pretendard"/>
+                <a:ea typeface="Pretendard"/>
+                <a:cs typeface="Pretendard"/>
               </a:rPr>
               <a:t>future_block</a:t>
             </a:r>
@@ -7153,6 +7303,8 @@
                   <a:srgbClr val="FFFFFF"/>
                 </a:solidFill>
                 <a:latin typeface="Pretendard"/>
+                <a:ea typeface="Pretendard"/>
+                <a:cs typeface="Pretendard"/>
               </a:rPr>
               <a:t>BL-015 tf_module 산업용수 활성화 TF</a:t>
             </a:r>
@@ -7205,6 +7357,8 @@
                   <a:srgbClr val="000359"/>
                 </a:solidFill>
                 <a:latin typeface="Pretendard"/>
+                <a:ea typeface="Pretendard"/>
+                <a:cs typeface="Pretendard"/>
               </a:rPr>
               <a:t/>
             </a:r>
@@ -7257,6 +7411,8 @@
                   <a:srgbClr val="3B4951"/>
                 </a:solidFill>
                 <a:latin typeface="Pretendard"/>
+                <a:ea typeface="Pretendard"/>
+                <a:cs typeface="Pretendard"/>
               </a:rPr>
               <a:t>ribbon_title</a:t>
             </a:r>
@@ -7309,6 +7465,8 @@
                   <a:srgbClr val="3B4951"/>
                 </a:solidFill>
                 <a:latin typeface="Pretendard"/>
+                <a:ea typeface="Pretendard"/>
+                <a:cs typeface="Pretendard"/>
               </a:rPr>
               <a:t>flow_block</a:t>
             </a:r>
@@ -7361,6 +7519,8 @@
                   <a:srgbClr val="3B4951"/>
                 </a:solidFill>
                 <a:latin typeface="Pretendard"/>
+                <a:ea typeface="Pretendard"/>
+                <a:cs typeface="Pretendard"/>
               </a:rPr>
               <a:t>future_block</a:t>
             </a:r>
@@ -7429,6 +7589,8 @@
                   <a:srgbClr val="000359"/>
                 </a:solidFill>
                 <a:latin typeface="Pretendard"/>
+                <a:ea typeface="Pretendard"/>
+                <a:cs typeface="Pretendard"/>
               </a:rPr>
               <a:t>PG-04  Ⅳ-평가내용1-3  (p08)</a:t>
             </a:r>
@@ -7481,6 +7643,8 @@
                   <a:srgbClr val="000359"/>
                 </a:solidFill>
                 <a:latin typeface="Pretendard"/>
+                <a:ea typeface="Pretendard"/>
+                <a:cs typeface="Pretendard"/>
               </a:rPr>
               <a:t/>
             </a:r>
@@ -7535,6 +7699,8 @@
                   <a:srgbClr val="FFFFFF"/>
                 </a:solidFill>
                 <a:latin typeface="Pretendard"/>
+                <a:ea typeface="Pretendard"/>
+                <a:cs typeface="Pretendard"/>
               </a:rPr>
               <a:t>BL-004 section_bar </a:t>
             </a:r>
@@ -7589,6 +7755,8 @@
                   <a:srgbClr val="FFFFFF"/>
                 </a:solidFill>
                 <a:latin typeface="Pretendard"/>
+                <a:ea typeface="Pretendard"/>
+                <a:cs typeface="Pretendard"/>
               </a:rPr>
               <a:t>BL-016 labeled_block 선제적 제안·반영</a:t>
             </a:r>
@@ -7641,6 +7809,8 @@
                   <a:srgbClr val="000359"/>
                 </a:solidFill>
                 <a:latin typeface="Pretendard"/>
+                <a:ea typeface="Pretendard"/>
+                <a:cs typeface="Pretendard"/>
               </a:rPr>
               <a:t/>
             </a:r>
@@ -7693,6 +7863,8 @@
                   <a:srgbClr val="3B4951"/>
                 </a:solidFill>
                 <a:latin typeface="Pretendard"/>
+                <a:ea typeface="Pretendard"/>
+                <a:cs typeface="Pretendard"/>
               </a:rPr>
               <a:t>process_title_bar</a:t>
             </a:r>
@@ -7745,6 +7917,8 @@
                   <a:srgbClr val="3B4951"/>
                 </a:solidFill>
                 <a:latin typeface="Pretendard"/>
+                <a:ea typeface="Pretendard"/>
+                <a:cs typeface="Pretendard"/>
               </a:rPr>
               <a:t>roadmap_timeline</a:t>
             </a:r>
@@ -7797,6 +7971,8 @@
                   <a:srgbClr val="3B4951"/>
                 </a:solidFill>
                 <a:latin typeface="Pretendard"/>
+                <a:ea typeface="Pretendard"/>
+                <a:cs typeface="Pretendard"/>
               </a:rPr>
               <a:t>policy_bar</a:t>
             </a:r>
@@ -7849,6 +8025,8 @@
                   <a:srgbClr val="3B4951"/>
                 </a:solidFill>
                 <a:latin typeface="Pretendard"/>
+                <a:ea typeface="Pretendard"/>
+                <a:cs typeface="Pretendard"/>
               </a:rPr>
               <a:t>support_pair_bar</a:t>
             </a:r>
@@ -7901,6 +8079,8 @@
                   <a:srgbClr val="3B4951"/>
                 </a:solidFill>
                 <a:latin typeface="Pretendard"/>
+                <a:ea typeface="Pretendard"/>
+                <a:cs typeface="Pretendard"/>
               </a:rPr>
               <a:t>month_cols3</a:t>
             </a:r>
@@ -7953,6 +8133,8 @@
                   <a:srgbClr val="3B4951"/>
                 </a:solidFill>
                 <a:latin typeface="Pretendard"/>
+                <a:ea typeface="Pretendard"/>
+                <a:cs typeface="Pretendard"/>
               </a:rPr>
               <a:t>wide_message_bar</a:t>
             </a:r>
@@ -8005,6 +8187,8 @@
                   <a:srgbClr val="3B4951"/>
                 </a:solidFill>
                 <a:latin typeface="Pretendard"/>
+                <a:ea typeface="Pretendard"/>
+                <a:cs typeface="Pretendard"/>
               </a:rPr>
               <a:t>split_header</a:t>
             </a:r>
@@ -8057,6 +8241,8 @@
                   <a:srgbClr val="3B4951"/>
                 </a:solidFill>
                 <a:latin typeface="Pretendard"/>
+                <a:ea typeface="Pretendard"/>
+                <a:cs typeface="Pretendard"/>
               </a:rPr>
               <a:t>category_rows5</a:t>
             </a:r>
@@ -8111,6 +8297,8 @@
                   <a:srgbClr val="FFFFFF"/>
                 </a:solidFill>
                 <a:latin typeface="Pretendard"/>
+                <a:ea typeface="Pretendard"/>
+                <a:cs typeface="Pretendard"/>
               </a:rPr>
               <a:t>BL-017 labeled_block 정책 정합성 확보</a:t>
             </a:r>
@@ -8163,6 +8351,8 @@
                   <a:srgbClr val="000359"/>
                 </a:solidFill>
                 <a:latin typeface="Pretendard"/>
+                <a:ea typeface="Pretendard"/>
+                <a:cs typeface="Pretendard"/>
               </a:rPr>
               <a:t/>
             </a:r>
@@ -8215,6 +8405,8 @@
                   <a:srgbClr val="3B4951"/>
                 </a:solidFill>
                 <a:latin typeface="Pretendard"/>
+                <a:ea typeface="Pretendard"/>
+                <a:cs typeface="Pretendard"/>
               </a:rPr>
               <a:t>direction_bar</a:t>
             </a:r>
@@ -8267,6 +8459,8 @@
                   <a:srgbClr val="3B4951"/>
                 </a:solidFill>
                 <a:latin typeface="Pretendard"/>
+                <a:ea typeface="Pretendard"/>
+                <a:cs typeface="Pretendard"/>
               </a:rPr>
               <a:t>split_header</a:t>
             </a:r>
@@ -8319,6 +8513,8 @@
                   <a:srgbClr val="3B4951"/>
                 </a:solidFill>
                 <a:latin typeface="Pretendard"/>
+                <a:ea typeface="Pretendard"/>
+                <a:cs typeface="Pretendard"/>
               </a:rPr>
               <a:t>pill_rows4</a:t>
             </a:r>
@@ -8387,6 +8583,8 @@
                   <a:srgbClr val="000359"/>
                 </a:solidFill>
                 <a:latin typeface="Pretendard"/>
+                <a:ea typeface="Pretendard"/>
+                <a:cs typeface="Pretendard"/>
               </a:rPr>
               <a:t>PG-05  Ⅳ-평가내용1-4  (p09)</a:t>
             </a:r>
@@ -8439,6 +8637,8 @@
                   <a:srgbClr val="000359"/>
                 </a:solidFill>
                 <a:latin typeface="Pretendard"/>
+                <a:ea typeface="Pretendard"/>
+                <a:cs typeface="Pretendard"/>
               </a:rPr>
               <a:t/>
             </a:r>
@@ -8493,6 +8693,8 @@
                   <a:srgbClr val="FFFFFF"/>
                 </a:solidFill>
                 <a:latin typeface="Pretendard"/>
+                <a:ea typeface="Pretendard"/>
+                <a:cs typeface="Pretendard"/>
               </a:rPr>
               <a:t>BL-004 section_bar </a:t>
             </a:r>
@@ -8547,6 +8749,8 @@
                   <a:srgbClr val="FFFFFF"/>
                 </a:solidFill>
                 <a:latin typeface="Pretendard"/>
+                <a:ea typeface="Pretendard"/>
+                <a:cs typeface="Pretendard"/>
               </a:rPr>
               <a:t>BL-018 labeled_block 조정방향</a:t>
             </a:r>
@@ -8599,6 +8803,8 @@
                   <a:srgbClr val="000359"/>
                 </a:solidFill>
                 <a:latin typeface="Pretendard"/>
+                <a:ea typeface="Pretendard"/>
+                <a:cs typeface="Pretendard"/>
               </a:rPr>
               <a:t/>
             </a:r>
@@ -8653,6 +8859,8 @@
                   <a:srgbClr val="FFFFFF"/>
                 </a:solidFill>
                 <a:latin typeface="Pretendard"/>
+                <a:ea typeface="Pretendard"/>
+                <a:cs typeface="Pretendard"/>
               </a:rPr>
               <a:t>BL-019 labeled_block 진단 TOOL</a:t>
             </a:r>
@@ -8705,6 +8913,8 @@
                   <a:srgbClr val="000359"/>
                 </a:solidFill>
                 <a:latin typeface="Pretendard"/>
+                <a:ea typeface="Pretendard"/>
+                <a:cs typeface="Pretendard"/>
               </a:rPr>
               <a:t/>
             </a:r>
@@ -8757,6 +8967,8 @@
                   <a:srgbClr val="3B4951"/>
                 </a:solidFill>
                 <a:latin typeface="Pretendard"/>
+                <a:ea typeface="Pretendard"/>
+                <a:cs typeface="Pretendard"/>
               </a:rPr>
               <a:t>duo_header_plus</a:t>
             </a:r>
@@ -8809,6 +9021,8 @@
                   <a:srgbClr val="3B4951"/>
                 </a:solidFill>
                 <a:latin typeface="Pretendard"/>
+                <a:ea typeface="Pretendard"/>
+                <a:cs typeface="Pretendard"/>
               </a:rPr>
               <a:t>bullets2</a:t>
             </a:r>
@@ -8861,6 +9075,8 @@
                   <a:srgbClr val="3B4951"/>
                 </a:solidFill>
                 <a:latin typeface="Pretendard"/>
+                <a:ea typeface="Pretendard"/>
+                <a:cs typeface="Pretendard"/>
               </a:rPr>
               <a:t>caption2</a:t>
             </a:r>
@@ -8915,6 +9131,8 @@
                   <a:srgbClr val="FFFFFF"/>
                 </a:solidFill>
                 <a:latin typeface="Pretendard"/>
+                <a:ea typeface="Pretendard"/>
+                <a:cs typeface="Pretendard"/>
               </a:rPr>
               <a:t>BL-020 labeled_block 사업별 진단</a:t>
             </a:r>
@@ -8967,6 +9185,8 @@
                   <a:srgbClr val="000359"/>
                 </a:solidFill>
                 <a:latin typeface="Pretendard"/>
+                <a:ea typeface="Pretendard"/>
+                <a:cs typeface="Pretendard"/>
               </a:rPr>
               <a:t/>
             </a:r>
@@ -9019,6 +9239,8 @@
                   <a:srgbClr val="3B4951"/>
                 </a:solidFill>
                 <a:latin typeface="Pretendard"/>
+                <a:ea typeface="Pretendard"/>
+                <a:cs typeface="Pretendard"/>
               </a:rPr>
               <a:t>top_banner</a:t>
             </a:r>
@@ -9071,6 +9293,8 @@
                   <a:srgbClr val="3B4951"/>
                 </a:solidFill>
                 <a:latin typeface="Pretendard"/>
+                <a:ea typeface="Pretendard"/>
+                <a:cs typeface="Pretendard"/>
               </a:rPr>
               <a:t>split_header</a:t>
             </a:r>
@@ -9123,6 +9347,8 @@
                   <a:srgbClr val="3B4951"/>
                 </a:solidFill>
                 <a:latin typeface="Pretendard"/>
+                <a:ea typeface="Pretendard"/>
+                <a:cs typeface="Pretendard"/>
               </a:rPr>
               <a:t>left_stack_expand_new</a:t>
             </a:r>
@@ -9175,6 +9401,8 @@
                   <a:srgbClr val="3B4951"/>
                 </a:solidFill>
                 <a:latin typeface="Pretendard"/>
+                <a:ea typeface="Pretendard"/>
+                <a:cs typeface="Pretendard"/>
               </a:rPr>
               <a:t>right_two_step_eval</a:t>
             </a:r>
@@ -9229,6 +9457,8 @@
                   <a:srgbClr val="FFFFFF"/>
                 </a:solidFill>
                 <a:latin typeface="Pretendard"/>
+                <a:ea typeface="Pretendard"/>
+                <a:cs typeface="Pretendard"/>
               </a:rPr>
               <a:t>BL-021 labeled_block 사업유형 분류</a:t>
             </a:r>
@@ -9281,6 +9511,8 @@
                   <a:srgbClr val="000359"/>
                 </a:solidFill>
                 <a:latin typeface="Pretendard"/>
+                <a:ea typeface="Pretendard"/>
+                <a:cs typeface="Pretendard"/>
               </a:rPr>
               <a:t/>
             </a:r>
@@ -9333,6 +9565,8 @@
                   <a:srgbClr val="3B4951"/>
                 </a:solidFill>
                 <a:latin typeface="Pretendard"/>
+                <a:ea typeface="Pretendard"/>
+                <a:cs typeface="Pretendard"/>
               </a:rPr>
               <a:t>cols3_header</a:t>
             </a:r>
@@ -9385,6 +9619,8 @@
                   <a:srgbClr val="3B4951"/>
                 </a:solidFill>
                 <a:latin typeface="Pretendard"/>
+                <a:ea typeface="Pretendard"/>
+                <a:cs typeface="Pretendard"/>
               </a:rPr>
               <a:t>cols3_body</a:t>
             </a:r>
@@ -9439,6 +9675,8 @@
                   <a:srgbClr val="000359"/>
                 </a:solidFill>
                 <a:latin typeface="Pretendard"/>
+                <a:ea typeface="Pretendard"/>
+                <a:cs typeface="Pretendard"/>
               </a:rPr>
               <a:t>BL-022 divider_chevron </a:t>
             </a:r>
@@ -9493,6 +9731,8 @@
                   <a:srgbClr val="FFFFFF"/>
                 </a:solidFill>
                 <a:latin typeface="Pretendard"/>
+                <a:ea typeface="Pretendard"/>
+                <a:cs typeface="Pretendard"/>
               </a:rPr>
               <a:t>BL-023 labeled_block 사업 포트폴리오 재구성</a:t>
             </a:r>
@@ -9545,6 +9785,8 @@
                   <a:srgbClr val="000359"/>
                 </a:solidFill>
                 <a:latin typeface="Pretendard"/>
+                <a:ea typeface="Pretendard"/>
+                <a:cs typeface="Pretendard"/>
               </a:rPr>
               <a:t/>
             </a:r>
@@ -9597,6 +9839,8 @@
                   <a:srgbClr val="3B4951"/>
                 </a:solidFill>
                 <a:latin typeface="Pretendard"/>
+                <a:ea typeface="Pretendard"/>
+                <a:cs typeface="Pretendard"/>
               </a:rPr>
               <a:t>scatter_before</a:t>
             </a:r>
@@ -9649,6 +9893,8 @@
                   <a:srgbClr val="3B4951"/>
                 </a:solidFill>
                 <a:latin typeface="Pretendard"/>
+                <a:ea typeface="Pretendard"/>
+                <a:cs typeface="Pretendard"/>
               </a:rPr>
               <a:t>arrow</a:t>
             </a:r>
@@ -9701,6 +9947,8 @@
                   <a:srgbClr val="3B4951"/>
                 </a:solidFill>
                 <a:latin typeface="Pretendard"/>
+                <a:ea typeface="Pretendard"/>
+                <a:cs typeface="Pretendard"/>
               </a:rPr>
               <a:t>scatter_after</a:t>
             </a:r>
@@ -9753,6 +10001,8 @@
                   <a:srgbClr val="3B4951"/>
                 </a:solidFill>
                 <a:latin typeface="Pretendard"/>
+                <a:ea typeface="Pretendard"/>
+                <a:cs typeface="Pretendard"/>
               </a:rPr>
               <a:t>footnote_legend</a:t>
             </a:r>
@@ -9807,6 +10057,8 @@
                   <a:srgbClr val="000359"/>
                 </a:solidFill>
                 <a:latin typeface="Pretendard"/>
+                <a:ea typeface="Pretendard"/>
+                <a:cs typeface="Pretendard"/>
               </a:rPr>
               <a:t>BL-024 ribbon_title </a:t>
             </a:r>
@@ -9861,6 +10113,8 @@
                   <a:srgbClr val="FFFFFF"/>
                 </a:solidFill>
                 <a:latin typeface="Pretendard"/>
+                <a:ea typeface="Pretendard"/>
+                <a:cs typeface="Pretendard"/>
               </a:rPr>
               <a:t>BL-025 labeled_block 중장기 재무전략</a:t>
             </a:r>
@@ -9913,6 +10167,8 @@
                   <a:srgbClr val="000359"/>
                 </a:solidFill>
                 <a:latin typeface="Pretendard"/>
+                <a:ea typeface="Pretendard"/>
+                <a:cs typeface="Pretendard"/>
               </a:rPr>
               <a:t/>
             </a:r>
@@ -9965,6 +10221,8 @@
                   <a:srgbClr val="3B4951"/>
                 </a:solidFill>
                 <a:latin typeface="Pretendard"/>
+                <a:ea typeface="Pretendard"/>
+                <a:cs typeface="Pretendard"/>
               </a:rPr>
               <a:t>stacked_bar_chart</a:t>
             </a:r>
@@ -10017,6 +10275,8 @@
                   <a:srgbClr val="3B4951"/>
                 </a:solidFill>
                 <a:latin typeface="Pretendard"/>
+                <a:ea typeface="Pretendard"/>
+                <a:cs typeface="Pretendard"/>
               </a:rPr>
               <a:t>table_4rows_x3</a:t>
             </a:r>
@@ -10071,6 +10331,8 @@
                   <a:srgbClr val="FFFFFF"/>
                 </a:solidFill>
                 <a:latin typeface="Pretendard"/>
+                <a:ea typeface="Pretendard"/>
+                <a:cs typeface="Pretendard"/>
               </a:rPr>
               <a:t>BL-025 labeled_block 중장기 인력운용</a:t>
             </a:r>
@@ -10123,6 +10385,8 @@
                   <a:srgbClr val="000359"/>
                 </a:solidFill>
                 <a:latin typeface="Pretendard"/>
+                <a:ea typeface="Pretendard"/>
+                <a:cs typeface="Pretendard"/>
               </a:rPr>
               <a:t/>
             </a:r>
@@ -10175,6 +10439,8 @@
                   <a:srgbClr val="3B4951"/>
                 </a:solidFill>
                 <a:latin typeface="Pretendard"/>
+                <a:ea typeface="Pretendard"/>
+                <a:cs typeface="Pretendard"/>
               </a:rPr>
               <a:t>stacked_bar_chart</a:t>
             </a:r>
@@ -10227,6 +10493,8 @@
                   <a:srgbClr val="3B4951"/>
                 </a:solidFill>
                 <a:latin typeface="Pretendard"/>
+                <a:ea typeface="Pretendard"/>
+                <a:cs typeface="Pretendard"/>
               </a:rPr>
               <a:t>table_4rows_x3</a:t>
             </a:r>

</xml_diff>